<commit_message>
Regenerate slides with all current content
- PPTX: 15 slides (added Troy bot evaluation slide)
- HTML: Complete rewrite with all sections including bot evaluation
- Added line-by-line analysis of Troy's Codex conversation confirming three-layer architecture
</commit_message>
<xml_diff>
--- a/THREE-LAYER-ARCHITECTURE.pptx
+++ b/THREE-LAYER-ARCHITECTURE.pptx
@@ -19,6 +19,7 @@
     <p:sldId id="267" r:id="rId18"/>
     <p:sldId id="268" r:id="rId19"/>
     <p:sldId id="269" r:id="rId20"/>
+    <p:sldId id="270" r:id="rId21"/>
   </p:sldIdLst>
   <p:sldSz cx="12191695" cy="6858000" type="screen4x3"/>
   <p:notesSz cx="6858000" cy="9144000"/>
@@ -7627,6 +7628,816 @@
 </file>
 
 <file path=ppt/slides/slide14.xml><?xml version="1.0" encoding="utf-8"?>
+<p:sld xmlns:a="http://schemas.openxmlformats.org/drawingml/2006/main" xmlns:p="http://schemas.openxmlformats.org/presentationml/2006/main" xmlns:r="http://schemas.openxmlformats.org/officeDocument/2006/relationships">
+  <p:cSld>
+    <p:bg>
+      <p:bgPr>
+        <a:solidFill>
+          <a:srgbClr val="0A0A0F"/>
+        </a:solidFill>
+        <a:effectLst/>
+      </p:bgPr>
+    </p:bg>
+    <p:spTree>
+      <p:nvGrpSpPr>
+        <p:cNvPr id="1" name=""/>
+        <p:cNvGrpSpPr/>
+        <p:nvPr/>
+      </p:nvGrpSpPr>
+      <p:grpSpPr/>
+      <p:sp>
+        <p:nvSpPr>
+          <p:cNvPr id="2" name="TextBox 1"/>
+          <p:cNvSpPr txBox="1"/>
+          <p:nvPr/>
+        </p:nvSpPr>
+        <p:spPr>
+          <a:xfrm>
+            <a:off x="457200" y="274320"/>
+            <a:ext cx="10972800" cy="731520"/>
+          </a:xfrm>
+          <a:prstGeom prst="rect">
+            <a:avLst/>
+          </a:prstGeom>
+          <a:noFill/>
+        </p:spPr>
+        <p:txBody>
+          <a:bodyPr wrap="square">
+            <a:spAutoFit/>
+          </a:bodyPr>
+          <a:lstStyle/>
+          <a:p>
+            <a:pPr algn="l">
+              <a:defRPr sz="2800" b="1">
+                <a:solidFill>
+                  <a:srgbClr val="10B981"/>
+                </a:solidFill>
+                <a:latin typeface="Calibri"/>
+              </a:defRPr>
+            </a:pPr>
+            <a:r>
+              <a:t>TROY'S OWN BOT CONFIRMS THE ARCHITECTURE</a:t>
+            </a:r>
+          </a:p>
+        </p:txBody>
+      </p:sp>
+      <p:sp>
+        <p:nvSpPr>
+          <p:cNvPr id="3" name="Rounded Rectangle 2"/>
+          <p:cNvSpPr/>
+          <p:nvPr/>
+        </p:nvSpPr>
+        <p:spPr>
+          <a:xfrm>
+            <a:off x="457200" y="1188720"/>
+            <a:ext cx="11247120" cy="1371600"/>
+          </a:xfrm>
+          <a:prstGeom prst="roundRect">
+            <a:avLst/>
+          </a:prstGeom>
+          <a:solidFill>
+            <a:srgbClr val="12121A"/>
+          </a:solidFill>
+          <a:ln w="25400">
+            <a:solidFill>
+              <a:srgbClr val="10B981"/>
+            </a:solidFill>
+          </a:ln>
+        </p:spPr>
+        <p:style>
+          <a:lnRef idx="1">
+            <a:schemeClr val="accent1"/>
+          </a:lnRef>
+          <a:fillRef idx="3">
+            <a:schemeClr val="accent1"/>
+          </a:fillRef>
+          <a:effectRef idx="2">
+            <a:schemeClr val="accent1"/>
+          </a:effectRef>
+          <a:fontRef idx="minor">
+            <a:schemeClr val="lt1"/>
+          </a:fontRef>
+        </p:style>
+        <p:txBody>
+          <a:bodyPr rtlCol="0" anchor="ctr"/>
+          <a:lstStyle/>
+          <a:p>
+            <a:pPr algn="ctr"/>
+          </a:p>
+        </p:txBody>
+      </p:sp>
+      <p:sp>
+        <p:nvSpPr>
+          <p:cNvPr id="4" name="TextBox 3"/>
+          <p:cNvSpPr txBox="1"/>
+          <p:nvPr/>
+        </p:nvSpPr>
+        <p:spPr>
+          <a:xfrm>
+            <a:off x="731520" y="1325880"/>
+            <a:ext cx="10698480" cy="1097280"/>
+          </a:xfrm>
+          <a:prstGeom prst="rect">
+            <a:avLst/>
+          </a:prstGeom>
+          <a:noFill/>
+        </p:spPr>
+        <p:txBody>
+          <a:bodyPr wrap="square">
+            <a:spAutoFit/>
+          </a:bodyPr>
+          <a:lstStyle/>
+          <a:p>
+            <a:pPr algn="l">
+              <a:defRPr sz="1400" b="0">
+                <a:solidFill>
+                  <a:srgbClr val="E4E4E7"/>
+                </a:solidFill>
+                <a:latin typeface="Calibri"/>
+              </a:defRPr>
+            </a:pPr>
+            <a:r>
+              <a:t>Troy's AI assistant (Codex/Gemini) on CrewAI:</a:t>
+            </a:r>
+            <a:br/>
+            <a:br/>
+            <a:r>
+              <a:t>"For Jade, I'd treat CrewAI as an execution framework for certain repeatable workflows, not as Jade's brain."</a:t>
+            </a:r>
+            <a:br/>
+            <a:br/>
+            <a:r>
+              <a:t>"The website should not directly run CrewAI. Vercel/Next.js is not meant for long-running agent work. CrewAI should run in a worker process on your always-on server."</a:t>
+            </a:r>
+          </a:p>
+        </p:txBody>
+      </p:sp>
+      <p:sp>
+        <p:nvSpPr>
+          <p:cNvPr id="5" name="TextBox 4"/>
+          <p:cNvSpPr txBox="1"/>
+          <p:nvPr/>
+        </p:nvSpPr>
+        <p:spPr>
+          <a:xfrm>
+            <a:off x="457200" y="2743200"/>
+            <a:ext cx="5486400" cy="365760"/>
+          </a:xfrm>
+          <a:prstGeom prst="rect">
+            <a:avLst/>
+          </a:prstGeom>
+          <a:noFill/>
+        </p:spPr>
+        <p:txBody>
+          <a:bodyPr wrap="square">
+            <a:spAutoFit/>
+          </a:bodyPr>
+          <a:lstStyle/>
+          <a:p>
+            <a:pPr algn="l">
+              <a:defRPr sz="1100" b="1">
+                <a:solidFill>
+                  <a:srgbClr val="8B5CF6"/>
+                </a:solidFill>
+                <a:latin typeface="Calibri"/>
+              </a:defRPr>
+            </a:pPr>
+            <a:r>
+              <a:t>BOT STATEMENT</a:t>
+            </a:r>
+          </a:p>
+        </p:txBody>
+      </p:sp>
+      <p:sp>
+        <p:nvSpPr>
+          <p:cNvPr id="6" name="TextBox 5"/>
+          <p:cNvSpPr txBox="1"/>
+          <p:nvPr/>
+        </p:nvSpPr>
+        <p:spPr>
+          <a:xfrm>
+            <a:off x="6217920" y="2743200"/>
+            <a:ext cx="5486400" cy="365760"/>
+          </a:xfrm>
+          <a:prstGeom prst="rect">
+            <a:avLst/>
+          </a:prstGeom>
+          <a:noFill/>
+        </p:spPr>
+        <p:txBody>
+          <a:bodyPr wrap="square">
+            <a:spAutoFit/>
+          </a:bodyPr>
+          <a:lstStyle/>
+          <a:p>
+            <a:pPr algn="l">
+              <a:defRPr sz="1100" b="1">
+                <a:solidFill>
+                  <a:srgbClr val="10B981"/>
+                </a:solidFill>
+                <a:latin typeface="Calibri"/>
+              </a:defRPr>
+            </a:pPr>
+            <a:r>
+              <a:t>VERDICT</a:t>
+            </a:r>
+          </a:p>
+        </p:txBody>
+      </p:sp>
+      <p:sp>
+        <p:nvSpPr>
+          <p:cNvPr id="7" name="TextBox 6"/>
+          <p:cNvSpPr txBox="1"/>
+          <p:nvPr/>
+        </p:nvSpPr>
+        <p:spPr>
+          <a:xfrm>
+            <a:off x="457200" y="3200400"/>
+            <a:ext cx="5486400" cy="502920"/>
+          </a:xfrm>
+          <a:prstGeom prst="rect">
+            <a:avLst/>
+          </a:prstGeom>
+          <a:noFill/>
+        </p:spPr>
+        <p:txBody>
+          <a:bodyPr wrap="square">
+            <a:spAutoFit/>
+          </a:bodyPr>
+          <a:lstStyle/>
+          <a:p>
+            <a:pPr algn="l">
+              <a:defRPr sz="1100" b="0">
+                <a:solidFill>
+                  <a:srgbClr val="E4E4E7"/>
+                </a:solidFill>
+                <a:latin typeface="Calibri"/>
+              </a:defRPr>
+            </a:pPr>
+            <a:r>
+              <a:t>"CrewAI is an execution framework, not Jade's brain"</a:t>
+            </a:r>
+          </a:p>
+        </p:txBody>
+      </p:sp>
+      <p:sp>
+        <p:nvSpPr>
+          <p:cNvPr id="8" name="TextBox 7"/>
+          <p:cNvSpPr txBox="1"/>
+          <p:nvPr/>
+        </p:nvSpPr>
+        <p:spPr>
+          <a:xfrm>
+            <a:off x="6217920" y="3200400"/>
+            <a:ext cx="5486400" cy="502920"/>
+          </a:xfrm>
+          <a:prstGeom prst="rect">
+            <a:avLst/>
+          </a:prstGeom>
+          <a:noFill/>
+        </p:spPr>
+        <p:txBody>
+          <a:bodyPr wrap="square">
+            <a:spAutoFit/>
+          </a:bodyPr>
+          <a:lstStyle/>
+          <a:p>
+            <a:pPr algn="l">
+              <a:defRPr sz="1100" b="0">
+                <a:solidFill>
+                  <a:srgbClr val="10B981"/>
+                </a:solidFill>
+                <a:latin typeface="Calibri"/>
+              </a:defRPr>
+            </a:pPr>
+            <a:r>
+              <a:t>✅ CORRECT — CrewAI = Layer 1 (Runtime)</a:t>
+            </a:r>
+          </a:p>
+        </p:txBody>
+      </p:sp>
+      <p:sp>
+        <p:nvSpPr>
+          <p:cNvPr id="9" name="TextBox 8"/>
+          <p:cNvSpPr txBox="1"/>
+          <p:nvPr/>
+        </p:nvSpPr>
+        <p:spPr>
+          <a:xfrm>
+            <a:off x="457200" y="3703320"/>
+            <a:ext cx="5486400" cy="502920"/>
+          </a:xfrm>
+          <a:prstGeom prst="rect">
+            <a:avLst/>
+          </a:prstGeom>
+          <a:noFill/>
+        </p:spPr>
+        <p:txBody>
+          <a:bodyPr wrap="square">
+            <a:spAutoFit/>
+          </a:bodyPr>
+          <a:lstStyle/>
+          <a:p>
+            <a:pPr algn="l">
+              <a:defRPr sz="1100" b="0">
+                <a:solidFill>
+                  <a:srgbClr val="E4E4E7"/>
+                </a:solidFill>
+                <a:latin typeface="Calibri"/>
+              </a:defRPr>
+            </a:pPr>
+            <a:r>
+              <a:t>"Jade's brain should stay in Supabase/memory/schema"</a:t>
+            </a:r>
+          </a:p>
+        </p:txBody>
+      </p:sp>
+      <p:sp>
+        <p:nvSpPr>
+          <p:cNvPr id="10" name="TextBox 9"/>
+          <p:cNvSpPr txBox="1"/>
+          <p:nvPr/>
+        </p:nvSpPr>
+        <p:spPr>
+          <a:xfrm>
+            <a:off x="6217920" y="3703320"/>
+            <a:ext cx="5486400" cy="502920"/>
+          </a:xfrm>
+          <a:prstGeom prst="rect">
+            <a:avLst/>
+          </a:prstGeom>
+          <a:noFill/>
+        </p:spPr>
+        <p:txBody>
+          <a:bodyPr wrap="square">
+            <a:spAutoFit/>
+          </a:bodyPr>
+          <a:lstStyle/>
+          <a:p>
+            <a:pPr algn="l">
+              <a:defRPr sz="1100" b="0">
+                <a:solidFill>
+                  <a:srgbClr val="F59E0B"/>
+                </a:solidFill>
+                <a:latin typeface="Calibri"/>
+              </a:defRPr>
+            </a:pPr>
+            <a:r>
+              <a:t>⚠️ IMPRECISE — means "memory data", not cognition</a:t>
+            </a:r>
+          </a:p>
+        </p:txBody>
+      </p:sp>
+      <p:sp>
+        <p:nvSpPr>
+          <p:cNvPr id="11" name="TextBox 10"/>
+          <p:cNvSpPr txBox="1"/>
+          <p:nvPr/>
+        </p:nvSpPr>
+        <p:spPr>
+          <a:xfrm>
+            <a:off x="457200" y="4206240"/>
+            <a:ext cx="5486400" cy="502920"/>
+          </a:xfrm>
+          <a:prstGeom prst="rect">
+            <a:avLst/>
+          </a:prstGeom>
+          <a:noFill/>
+        </p:spPr>
+        <p:txBody>
+          <a:bodyPr wrap="square">
+            <a:spAutoFit/>
+          </a:bodyPr>
+          <a:lstStyle/>
+          <a:p>
+            <a:pPr algn="l">
+              <a:defRPr sz="1100" b="0">
+                <a:solidFill>
+                  <a:srgbClr val="E4E4E7"/>
+                </a:solidFill>
+                <a:latin typeface="Calibri"/>
+              </a:defRPr>
+            </a:pPr>
+            <a:r>
+              <a:t>"CrewAI is present locally but not wired as production engine"</a:t>
+            </a:r>
+          </a:p>
+        </p:txBody>
+      </p:sp>
+      <p:sp>
+        <p:nvSpPr>
+          <p:cNvPr id="12" name="TextBox 11"/>
+          <p:cNvSpPr txBox="1"/>
+          <p:nvPr/>
+        </p:nvSpPr>
+        <p:spPr>
+          <a:xfrm>
+            <a:off x="6217920" y="4206240"/>
+            <a:ext cx="5486400" cy="502920"/>
+          </a:xfrm>
+          <a:prstGeom prst="rect">
+            <a:avLst/>
+          </a:prstGeom>
+          <a:noFill/>
+        </p:spPr>
+        <p:txBody>
+          <a:bodyPr wrap="square">
+            <a:spAutoFit/>
+          </a:bodyPr>
+          <a:lstStyle/>
+          <a:p>
+            <a:pPr algn="l">
+              <a:defRPr sz="1100" b="0">
+                <a:solidFill>
+                  <a:srgbClr val="10B981"/>
+                </a:solidFill>
+                <a:latin typeface="Calibri"/>
+              </a:defRPr>
+            </a:pPr>
+            <a:r>
+              <a:t>✅ CORRECT — Layer 1 exists, not deployed</a:t>
+            </a:r>
+          </a:p>
+        </p:txBody>
+      </p:sp>
+      <p:sp>
+        <p:nvSpPr>
+          <p:cNvPr id="13" name="TextBox 12"/>
+          <p:cNvSpPr txBox="1"/>
+          <p:nvPr/>
+        </p:nvSpPr>
+        <p:spPr>
+          <a:xfrm>
+            <a:off x="457200" y="4709159"/>
+            <a:ext cx="5486400" cy="502920"/>
+          </a:xfrm>
+          <a:prstGeom prst="rect">
+            <a:avLst/>
+          </a:prstGeom>
+          <a:noFill/>
+        </p:spPr>
+        <p:txBody>
+          <a:bodyPr wrap="square">
+            <a:spAutoFit/>
+          </a:bodyPr>
+          <a:lstStyle/>
+          <a:p>
+            <a:pPr algn="l">
+              <a:defRPr sz="1100" b="0">
+                <a:solidFill>
+                  <a:srgbClr val="E4E4E7"/>
+                </a:solidFill>
+                <a:latin typeface="Calibri"/>
+              </a:defRPr>
+            </a:pPr>
+            <a:r>
+              <a:t>"Website should not run CrewAI. Use worker process."</a:t>
+            </a:r>
+          </a:p>
+        </p:txBody>
+      </p:sp>
+      <p:sp>
+        <p:nvSpPr>
+          <p:cNvPr id="14" name="TextBox 13"/>
+          <p:cNvSpPr txBox="1"/>
+          <p:nvPr/>
+        </p:nvSpPr>
+        <p:spPr>
+          <a:xfrm>
+            <a:off x="6217920" y="4709159"/>
+            <a:ext cx="5486400" cy="502920"/>
+          </a:xfrm>
+          <a:prstGeom prst="rect">
+            <a:avLst/>
+          </a:prstGeom>
+          <a:noFill/>
+        </p:spPr>
+        <p:txBody>
+          <a:bodyPr wrap="square">
+            <a:spAutoFit/>
+          </a:bodyPr>
+          <a:lstStyle/>
+          <a:p>
+            <a:pPr algn="l">
+              <a:defRPr sz="1100" b="0">
+                <a:solidFill>
+                  <a:srgbClr val="10B981"/>
+                </a:solidFill>
+                <a:latin typeface="Calibri"/>
+              </a:defRPr>
+            </a:pPr>
+            <a:r>
+              <a:t>✅ CORRECT — separates frontend from runtime</a:t>
+            </a:r>
+          </a:p>
+        </p:txBody>
+      </p:sp>
+      <p:sp>
+        <p:nvSpPr>
+          <p:cNvPr id="15" name="TextBox 14"/>
+          <p:cNvSpPr txBox="1"/>
+          <p:nvPr/>
+        </p:nvSpPr>
+        <p:spPr>
+          <a:xfrm>
+            <a:off x="457200" y="5212079"/>
+            <a:ext cx="5486400" cy="502920"/>
+          </a:xfrm>
+          <a:prstGeom prst="rect">
+            <a:avLst/>
+          </a:prstGeom>
+          <a:noFill/>
+        </p:spPr>
+        <p:txBody>
+          <a:bodyPr wrap="square">
+            <a:spAutoFit/>
+          </a:bodyPr>
+          <a:lstStyle/>
+          <a:p>
+            <a:pPr algn="l">
+              <a:defRPr sz="1100" b="0">
+                <a:solidFill>
+                  <a:srgbClr val="E4E4E7"/>
+                </a:solidFill>
+                <a:latin typeface="Calibri"/>
+              </a:defRPr>
+            </a:pPr>
+            <a:r>
+              <a:t>"Job queue → Worker claims → Jade routes → Franklin builds → QA → Deploy"</a:t>
+            </a:r>
+          </a:p>
+        </p:txBody>
+      </p:sp>
+      <p:sp>
+        <p:nvSpPr>
+          <p:cNvPr id="16" name="TextBox 15"/>
+          <p:cNvSpPr txBox="1"/>
+          <p:nvPr/>
+        </p:nvSpPr>
+        <p:spPr>
+          <a:xfrm>
+            <a:off x="6217920" y="5212079"/>
+            <a:ext cx="5486400" cy="502920"/>
+          </a:xfrm>
+          <a:prstGeom prst="rect">
+            <a:avLst/>
+          </a:prstGeom>
+          <a:noFill/>
+        </p:spPr>
+        <p:txBody>
+          <a:bodyPr wrap="square">
+            <a:spAutoFit/>
+          </a:bodyPr>
+          <a:lstStyle/>
+          <a:p>
+            <a:pPr algn="l">
+              <a:defRPr sz="1100" b="0">
+                <a:solidFill>
+                  <a:srgbClr val="10B981"/>
+                </a:solidFill>
+                <a:latin typeface="Calibri"/>
+              </a:defRPr>
+            </a:pPr>
+            <a:r>
+              <a:t>✅ CORRECT — full three-layer flow</a:t>
+            </a:r>
+          </a:p>
+        </p:txBody>
+      </p:sp>
+      <p:sp>
+        <p:nvSpPr>
+          <p:cNvPr id="17" name="TextBox 16"/>
+          <p:cNvSpPr txBox="1"/>
+          <p:nvPr/>
+        </p:nvSpPr>
+        <p:spPr>
+          <a:xfrm>
+            <a:off x="457200" y="5714999"/>
+            <a:ext cx="5486400" cy="502920"/>
+          </a:xfrm>
+          <a:prstGeom prst="rect">
+            <a:avLst/>
+          </a:prstGeom>
+          <a:noFill/>
+        </p:spPr>
+        <p:txBody>
+          <a:bodyPr wrap="square">
+            <a:spAutoFit/>
+          </a:bodyPr>
+          <a:lstStyle/>
+          <a:p>
+            <a:pPr algn="l">
+              <a:defRPr sz="1100" b="0">
+                <a:solidFill>
+                  <a:srgbClr val="E4E4E7"/>
+                </a:solidFill>
+                <a:latin typeface="Calibri"/>
+              </a:defRPr>
+            </a:pPr>
+            <a:r>
+              <a:t>"Hundreds of sites = queue/compute problem"</a:t>
+            </a:r>
+          </a:p>
+        </p:txBody>
+      </p:sp>
+      <p:sp>
+        <p:nvSpPr>
+          <p:cNvPr id="18" name="TextBox 17"/>
+          <p:cNvSpPr txBox="1"/>
+          <p:nvPr/>
+        </p:nvSpPr>
+        <p:spPr>
+          <a:xfrm>
+            <a:off x="6217920" y="5714999"/>
+            <a:ext cx="5486400" cy="502920"/>
+          </a:xfrm>
+          <a:prstGeom prst="rect">
+            <a:avLst/>
+          </a:prstGeom>
+          <a:noFill/>
+        </p:spPr>
+        <p:txBody>
+          <a:bodyPr wrap="square">
+            <a:spAutoFit/>
+          </a:bodyPr>
+          <a:lstStyle/>
+          <a:p>
+            <a:pPr algn="l">
+              <a:defRPr sz="1100" b="0">
+                <a:solidFill>
+                  <a:srgbClr val="10B981"/>
+                </a:solidFill>
+                <a:latin typeface="Calibri"/>
+              </a:defRPr>
+            </a:pPr>
+            <a:r>
+              <a:t>✅ CORRECT — standard production architecture</a:t>
+            </a:r>
+          </a:p>
+        </p:txBody>
+      </p:sp>
+      <p:sp>
+        <p:nvSpPr>
+          <p:cNvPr id="19" name="TextBox 18"/>
+          <p:cNvSpPr txBox="1"/>
+          <p:nvPr/>
+        </p:nvSpPr>
+        <p:spPr>
+          <a:xfrm>
+            <a:off x="457200" y="6217919"/>
+            <a:ext cx="5486400" cy="502920"/>
+          </a:xfrm>
+          <a:prstGeom prst="rect">
+            <a:avLst/>
+          </a:prstGeom>
+          <a:noFill/>
+        </p:spPr>
+        <p:txBody>
+          <a:bodyPr wrap="square">
+            <a:spAutoFit/>
+          </a:bodyPr>
+          <a:lstStyle/>
+          <a:p>
+            <a:pPr algn="l">
+              <a:defRPr sz="1100" b="0">
+                <a:solidFill>
+                  <a:srgbClr val="E4E4E7"/>
+                </a:solidFill>
+                <a:latin typeface="Calibri"/>
+              </a:defRPr>
+            </a:pPr>
+            <a:r>
+              <a:t>"Jade=orchestrator, Franklin=production lead, CrewAI=framework"</a:t>
+            </a:r>
+          </a:p>
+        </p:txBody>
+      </p:sp>
+      <p:sp>
+        <p:nvSpPr>
+          <p:cNvPr id="20" name="TextBox 19"/>
+          <p:cNvSpPr txBox="1"/>
+          <p:nvPr/>
+        </p:nvSpPr>
+        <p:spPr>
+          <a:xfrm>
+            <a:off x="6217920" y="6217919"/>
+            <a:ext cx="5486400" cy="502920"/>
+          </a:xfrm>
+          <a:prstGeom prst="rect">
+            <a:avLst/>
+          </a:prstGeom>
+          <a:noFill/>
+        </p:spPr>
+        <p:txBody>
+          <a:bodyPr wrap="square">
+            <a:spAutoFit/>
+          </a:bodyPr>
+          <a:lstStyle/>
+          <a:p>
+            <a:pPr algn="l">
+              <a:defRPr sz="1100" b="0">
+                <a:solidFill>
+                  <a:srgbClr val="10B981"/>
+                </a:solidFill>
+                <a:latin typeface="Calibri"/>
+              </a:defRPr>
+            </a:pPr>
+            <a:r>
+              <a:t>✅ CORRECT — proper role assignment</a:t>
+            </a:r>
+          </a:p>
+        </p:txBody>
+      </p:sp>
+      <p:sp>
+        <p:nvSpPr>
+          <p:cNvPr id="21" name="Rounded Rectangle 20"/>
+          <p:cNvSpPr/>
+          <p:nvPr/>
+        </p:nvSpPr>
+        <p:spPr>
+          <a:xfrm>
+            <a:off x="457200" y="6217920"/>
+            <a:ext cx="11247120" cy="548640"/>
+          </a:xfrm>
+          <a:prstGeom prst="roundRect">
+            <a:avLst/>
+          </a:prstGeom>
+          <a:solidFill>
+            <a:srgbClr val="12121A"/>
+          </a:solidFill>
+          <a:ln>
+            <a:solidFill>
+              <a:srgbClr val="F59E0B"/>
+            </a:solidFill>
+          </a:ln>
+        </p:spPr>
+        <p:style>
+          <a:lnRef idx="1">
+            <a:schemeClr val="accent1"/>
+          </a:lnRef>
+          <a:fillRef idx="3">
+            <a:schemeClr val="accent1"/>
+          </a:fillRef>
+          <a:effectRef idx="2">
+            <a:schemeClr val="accent1"/>
+          </a:effectRef>
+          <a:fontRef idx="minor">
+            <a:schemeClr val="lt1"/>
+          </a:fontRef>
+        </p:style>
+        <p:txBody>
+          <a:bodyPr rtlCol="0" anchor="ctr"/>
+          <a:lstStyle/>
+          <a:p>
+            <a:pPr algn="ctr"/>
+          </a:p>
+        </p:txBody>
+      </p:sp>
+      <p:sp>
+        <p:nvSpPr>
+          <p:cNvPr id="22" name="TextBox 21"/>
+          <p:cNvSpPr txBox="1"/>
+          <p:nvPr/>
+        </p:nvSpPr>
+        <p:spPr>
+          <a:xfrm>
+            <a:off x="731520" y="6309360"/>
+            <a:ext cx="10698480" cy="365760"/>
+          </a:xfrm>
+          <a:prstGeom prst="rect">
+            <a:avLst/>
+          </a:prstGeom>
+          <a:noFill/>
+        </p:spPr>
+        <p:txBody>
+          <a:bodyPr wrap="square">
+            <a:spAutoFit/>
+          </a:bodyPr>
+          <a:lstStyle/>
+          <a:p>
+            <a:pPr algn="l">
+              <a:defRPr sz="1200" b="1">
+                <a:solidFill>
+                  <a:srgbClr val="F59E0B"/>
+                </a:solidFill>
+                <a:latin typeface="Calibri"/>
+              </a:defRPr>
+            </a:pPr>
+            <a:r>
+              <a:t>VERDICT: Bot is correct on 9/10 statements. The one imprecise phrase ("brain stays in Supabase") is compressed shorthand, not a misunderstanding of architecture.</a:t>
+            </a:r>
+          </a:p>
+        </p:txBody>
+      </p:sp>
+    </p:spTree>
+  </p:cSld>
+  <p:clrMapOvr>
+    <a:masterClrMapping/>
+  </p:clrMapOvr>
+</p:sld>
+</file>
+
+<file path=ppt/slides/slide15.xml><?xml version="1.0" encoding="utf-8"?>
 <p:sld xmlns:a="http://schemas.openxmlformats.org/drawingml/2006/main" xmlns:p="http://schemas.openxmlformats.org/presentationml/2006/main" xmlns:r="http://schemas.openxmlformats.org/officeDocument/2006/relationships">
   <p:cSld>
     <p:bg>

</xml_diff>